<commit_message>
Remove Virbac data from slide 2 (2026-05-14)
</commit_message>
<xml_diff>
--- a/BI-Pet-Competitor-Ecosystem-2026-CN-V2.pptx
+++ b/BI-Pet-Competitor-Ecosystem-2026-CN-V2.pptx
@@ -8064,7 +8064,7 @@
                 <a:ea typeface="Arial" pitchFamily="34" charset="-122"/>
                 <a:cs typeface="Arial" pitchFamily="34" charset="-120"/>
               </a:rPr>
-              <a:t>3.84亿欧元</a:t>
+              <a:t/>
             </a:r>
             <a:endParaRPr lang="en-US" sz="1800" dirty="0"/>
           </a:p>
@@ -8103,7 +8103,7 @@
                 <a:ea typeface="Arial" pitchFamily="34" charset="-122"/>
                 <a:cs typeface="Arial" pitchFamily="34" charset="-120"/>
               </a:rPr>
-              <a:t>+7.7%</a:t>
+              <a:t/>
             </a:r>
             <a:endParaRPr lang="en-US" sz="1300" dirty="0"/>
           </a:p>
@@ -8142,7 +8142,7 @@
                 <a:ea typeface="Arial" pitchFamily="34" charset="-122"/>
                 <a:cs typeface="Arial" pitchFamily="34" charset="-120"/>
               </a:rPr>
-              <a:t>约4.14亿美元</a:t>
+              <a:t/>
             </a:r>
             <a:endParaRPr lang="en-US" sz="800" dirty="0"/>
           </a:p>
@@ -8201,7 +8201,7 @@
                 <a:ea typeface="Arial" pitchFamily="34" charset="-122"/>
                 <a:cs typeface="Arial" pitchFamily="34" charset="-120"/>
               </a:rPr>
-              <a:t>▲ 宠物+9.9% · 北美+20.7%</a:t>
+              <a:t/>
             </a:r>
             <a:endParaRPr lang="en-US" sz="850" dirty="0"/>
           </a:p>
@@ -8240,7 +8240,7 @@
                 <a:ea typeface="Arial" pitchFamily="34" charset="-122"/>
                 <a:cs typeface="Arial" pitchFamily="34" charset="-120"/>
               </a:rPr>
-              <a:t>▼ 欧洲增长温和+2%</a:t>
+              <a:t/>
             </a:r>
             <a:endParaRPr lang="en-US" sz="850" dirty="0"/>
           </a:p>

</xml_diff>

<commit_message>
Remove all Virbac content from slide 6 (2026-05-14)
</commit_message>
<xml_diff>
--- a/BI-Pet-Competitor-Ecosystem-2026-CN-V2.pptx
+++ b/BI-Pet-Competitor-Ecosystem-2026-CN-V2.pptx
@@ -14864,7 +14864,7 @@
                 <a:ea typeface="Arial" pitchFamily="34" charset="-122"/>
                 <a:cs typeface="Arial" pitchFamily="34" charset="-120"/>
               </a:rPr>
-              <a:t>Q1营收3.84亿欧元（~4.14亿美元，+7.7%）</a:t>
+              <a:t/>
             </a:r>
             <a:endParaRPr lang="en-US" sz="950" dirty="0"/>
           </a:p>
@@ -14882,7 +14882,7 @@
                 <a:ea typeface="Arial" pitchFamily="34" charset="-122"/>
                 <a:cs typeface="Arial" pitchFamily="34" charset="-120"/>
               </a:rPr>
-              <a:t>宠物板块同比+9.9%，最强增长引擎</a:t>
+              <a:t/>
             </a:r>
             <a:endParaRPr lang="en-US" sz="950" dirty="0"/>
           </a:p>
@@ -14900,7 +14900,7 @@
                 <a:ea typeface="Arial" pitchFamily="34" charset="-122"/>
                 <a:cs typeface="Arial" pitchFamily="34" charset="-120"/>
               </a:rPr>
-              <a:t>北美地区+20.7%（按固定汇率）</a:t>
+              <a:t/>
             </a:r>
             <a:endParaRPr lang="en-US" sz="950" dirty="0"/>
           </a:p>
@@ -14918,7 +14918,7 @@
                 <a:ea typeface="Arial" pitchFamily="34" charset="-122"/>
                 <a:cs typeface="Arial" pitchFamily="34" charset="-120"/>
               </a:rPr>
-              <a:t>"Supercharge"平台涵盖宠物全流程</a:t>
+              <a:t/>
             </a:r>
             <a:endParaRPr lang="en-US" sz="950" dirty="0"/>
           </a:p>
@@ -14936,7 +14936,7 @@
                 <a:ea typeface="Arial" pitchFamily="34" charset="-122"/>
                 <a:cs typeface="Arial" pitchFamily="34" charset="-120"/>
               </a:rPr>
-              <a:t>2025年12月收购猫甲亢药Thyronorm</a:t>
+              <a:t/>
             </a:r>
             <a:endParaRPr lang="en-US" sz="950" dirty="0"/>
           </a:p>
@@ -14954,7 +14954,7 @@
                 <a:ea typeface="Arial" pitchFamily="34" charset="-122"/>
                 <a:cs typeface="Arial" pitchFamily="34" charset="-120"/>
               </a:rPr>
-              <a:t>全球市场快速扩张，值得持续关注</a:t>
+              <a:t/>
             </a:r>
             <a:endParaRPr lang="en-US" sz="950" dirty="0"/>
           </a:p>

</xml_diff>

<commit_message>
Fix slide 10 & 11 readability: trend numbers white, gray text brighter, checkmarks red
</commit_message>
<xml_diff>
--- a/BI-Pet-Competitor-Ecosystem-2026-CN-V2.pptx
+++ b/BI-Pet-Competitor-Ecosystem-2026-CN-V2.pptx
@@ -3608,7 +3608,7 @@
                       <a:r>
                         <a:rPr lang="en-US" sz="1000" dirty="0">
                           <a:solidFill>
-                            <a:srgbClr val="666666"/>
+                            <a:srgbClr val="CC0000"/>
                           </a:solidFill>
                           <a:latin typeface="Arial" pitchFamily="34" charset="0"/>
                           <a:ea typeface="Arial" pitchFamily="34" charset="-122"/>
@@ -3968,7 +3968,7 @@
                       <a:r>
                         <a:rPr lang="en-US" sz="1000" dirty="0">
                           <a:solidFill>
-                            <a:srgbClr val="666666"/>
+                            <a:srgbClr val="CC0000"/>
                           </a:solidFill>
                           <a:latin typeface="Arial" pitchFamily="34" charset="0"/>
                           <a:ea typeface="Arial" pitchFamily="34" charset="-122"/>
@@ -4328,7 +4328,7 @@
                       <a:r>
                         <a:rPr lang="en-US" sz="1000" dirty="0">
                           <a:solidFill>
-                            <a:srgbClr val="666666"/>
+                            <a:srgbClr val="CC0000"/>
                           </a:solidFill>
                           <a:latin typeface="Arial" pitchFamily="34" charset="0"/>
                           <a:ea typeface="Arial" pitchFamily="34" charset="-122"/>
@@ -4591,7 +4591,7 @@
             <a:r>
               <a:rPr lang="en-US" sz="800" dirty="0">
                 <a:solidFill>
-                  <a:srgbClr val="898885"/>
+                  <a:srgbClr val="666666"/>
                 </a:solidFill>
                 <a:latin typeface="Arial" pitchFamily="34" charset="0"/>
                 <a:ea typeface="Arial" pitchFamily="34" charset="-122"/>
@@ -4617,7 +4617,7 @@
     <p:bg>
       <p:bgPr>
         <a:solidFill>
-          <a:srgbClr val="08312A"/>
+          <a:srgbClr val="FFFFFF"/>
         </a:solidFill>
       </p:bgPr>
     </p:bg>
@@ -4763,7 +4763,7 @@
             <a:r>
               <a:rPr lang="en-US" sz="1800" b="1" dirty="0">
                 <a:solidFill>
-                  <a:srgbClr val="08312A"/>
+                  <a:srgbClr val="FFFFFF"/>
                 </a:solidFill>
                 <a:latin typeface="Arial" pitchFamily="34" charset="0"/>
                 <a:ea typeface="Arial" pitchFamily="34" charset="-122"/>
@@ -4841,7 +4841,7 @@
             <a:r>
               <a:rPr lang="en-US" sz="900" dirty="0">
                 <a:solidFill>
-                  <a:srgbClr val="B7B6B2"/>
+                  <a:srgbClr val="D0D0D0"/>
                 </a:solidFill>
                 <a:latin typeface="Arial" pitchFamily="34" charset="0"/>
                 <a:ea typeface="Arial" pitchFamily="34" charset="-122"/>
@@ -4922,7 +4922,7 @@
             <a:r>
               <a:rPr lang="en-US" sz="1800" b="1" dirty="0">
                 <a:solidFill>
-                  <a:srgbClr val="08312A"/>
+                  <a:srgbClr val="FFFFFF"/>
                 </a:solidFill>
                 <a:latin typeface="Arial" pitchFamily="34" charset="0"/>
                 <a:ea typeface="Arial" pitchFamily="34" charset="-122"/>
@@ -5000,7 +5000,7 @@
             <a:r>
               <a:rPr lang="en-US" sz="900" dirty="0">
                 <a:solidFill>
-                  <a:srgbClr val="B7B6B2"/>
+                  <a:srgbClr val="D0D0D0"/>
                 </a:solidFill>
                 <a:latin typeface="Arial" pitchFamily="34" charset="0"/>
                 <a:ea typeface="Arial" pitchFamily="34" charset="-122"/>
@@ -5081,7 +5081,7 @@
             <a:r>
               <a:rPr lang="en-US" sz="1800" b="1" dirty="0">
                 <a:solidFill>
-                  <a:srgbClr val="08312A"/>
+                  <a:srgbClr val="FFFFFF"/>
                 </a:solidFill>
                 <a:latin typeface="Arial" pitchFamily="34" charset="0"/>
                 <a:ea typeface="Arial" pitchFamily="34" charset="-122"/>
@@ -5159,7 +5159,7 @@
             <a:r>
               <a:rPr lang="en-US" sz="900" dirty="0">
                 <a:solidFill>
-                  <a:srgbClr val="B7B6B2"/>
+                  <a:srgbClr val="D0D0D0"/>
                 </a:solidFill>
                 <a:latin typeface="Arial" pitchFamily="34" charset="0"/>
                 <a:ea typeface="Arial" pitchFamily="34" charset="-122"/>
@@ -5240,7 +5240,7 @@
             <a:r>
               <a:rPr lang="en-US" sz="1800" b="1" dirty="0">
                 <a:solidFill>
-                  <a:srgbClr val="08312A"/>
+                  <a:srgbClr val="FFFFFF"/>
                 </a:solidFill>
                 <a:latin typeface="Arial" pitchFamily="34" charset="0"/>
                 <a:ea typeface="Arial" pitchFamily="34" charset="-122"/>
@@ -5318,7 +5318,7 @@
             <a:r>
               <a:rPr lang="en-US" sz="900" dirty="0">
                 <a:solidFill>
-                  <a:srgbClr val="B7B6B2"/>
+                  <a:srgbClr val="D0D0D0"/>
                 </a:solidFill>
                 <a:latin typeface="Arial" pitchFamily="34" charset="0"/>
                 <a:ea typeface="Arial" pitchFamily="34" charset="-122"/>
@@ -5399,7 +5399,7 @@
             <a:r>
               <a:rPr lang="en-US" sz="1800" b="1" dirty="0">
                 <a:solidFill>
-                  <a:srgbClr val="08312A"/>
+                  <a:srgbClr val="FFFFFF"/>
                 </a:solidFill>
                 <a:latin typeface="Arial" pitchFamily="34" charset="0"/>
                 <a:ea typeface="Arial" pitchFamily="34" charset="-122"/>
@@ -5477,7 +5477,7 @@
             <a:r>
               <a:rPr lang="en-US" sz="900" dirty="0">
                 <a:solidFill>
-                  <a:srgbClr val="B7B6B2"/>
+                  <a:srgbClr val="D0D0D0"/>
                 </a:solidFill>
                 <a:latin typeface="Arial" pitchFamily="34" charset="0"/>
                 <a:ea typeface="Arial" pitchFamily="34" charset="-122"/>
@@ -5558,7 +5558,7 @@
             <a:r>
               <a:rPr lang="en-US" sz="1800" b="1" dirty="0">
                 <a:solidFill>
-                  <a:srgbClr val="08312A"/>
+                  <a:srgbClr val="FFFFFF"/>
                 </a:solidFill>
                 <a:latin typeface="Arial" pitchFamily="34" charset="0"/>
                 <a:ea typeface="Arial" pitchFamily="34" charset="-122"/>
@@ -5636,7 +5636,7 @@
             <a:r>
               <a:rPr lang="en-US" sz="900" dirty="0">
                 <a:solidFill>
-                  <a:srgbClr val="B7B6B2"/>
+                  <a:srgbClr val="D0D0D0"/>
                 </a:solidFill>
                 <a:latin typeface="Arial" pitchFamily="34" charset="0"/>
                 <a:ea typeface="Arial" pitchFamily="34" charset="-122"/>
@@ -5695,7 +5695,7 @@
             <a:r>
               <a:rPr lang="en-US" sz="1050" b="1" dirty="0">
                 <a:solidFill>
-                  <a:srgbClr val="08312A"/>
+                  <a:srgbClr val="FFFFFF"/>
                 </a:solidFill>
                 <a:latin typeface="Arial" pitchFamily="34" charset="0"/>
                 <a:ea typeface="Arial" pitchFamily="34" charset="-122"/>

</xml_diff>